<commit_message>
Show the vehicle demo on the slide that lists it
The four-demos slide listed four and showed three, and the missing one was the
vehicle, which is the textbook case the whole talk leans on. A row of four also
needed a width cap: heights were fixed and the row would simply have run off
both edges, so the height is now whatever makes the row fit the usable width.
</commit_message>
<xml_diff>
--- a/tutorial_HIL_driver.pptx
+++ b/tutorial_HIL_driver.pptx
@@ -14877,7 +14877,7 @@
       </p:sp>
       <p:pic>
         <p:nvPicPr>
-          <p:cNvPr id="4" name="Picture 3" descr="demo_go2.png"/>
+          <p:cNvPr id="4" name="Picture 3" descr="hmmwv.png"/>
           <p:cNvPicPr>
             <a:picLocks noChangeAspect="1"/>
           </p:cNvPicPr>
@@ -14891,8 +14891,8 @@
         </p:blipFill>
         <p:spPr>
           <a:xfrm>
-            <a:off x="2776407" y="3880104"/>
-            <a:ext cx="2181098" cy="1688592"/>
+            <a:off x="1535041" y="3880104"/>
+            <a:ext cx="2208413" cy="1688592"/>
           </a:xfrm>
           <a:prstGeom prst="rect">
             <a:avLst/>
@@ -14901,7 +14901,7 @@
       </p:pic>
       <p:pic>
         <p:nvPicPr>
-          <p:cNvPr id="5" name="Picture 4" descr="demo_arm.png"/>
+          <p:cNvPr id="5" name="Picture 4" descr="demo_go2.png"/>
           <p:cNvPicPr>
             <a:picLocks noChangeAspect="1"/>
           </p:cNvPicPr>
@@ -14915,8 +14915,8 @@
         </p:blipFill>
         <p:spPr>
           <a:xfrm>
-            <a:off x="5231825" y="3880104"/>
-            <a:ext cx="1725300" cy="1688592"/>
+            <a:off x="4017774" y="3880104"/>
+            <a:ext cx="2181098" cy="1688592"/>
           </a:xfrm>
           <a:prstGeom prst="rect">
             <a:avLst/>
@@ -14925,7 +14925,7 @@
       </p:pic>
       <p:pic>
         <p:nvPicPr>
-          <p:cNvPr id="6" name="Picture 5" descr="demo_push.png"/>
+          <p:cNvPr id="6" name="Picture 5" descr="demo_arm.png"/>
           <p:cNvPicPr>
             <a:picLocks noChangeAspect="1"/>
           </p:cNvPicPr>
@@ -14939,7 +14939,31 @@
         </p:blipFill>
         <p:spPr>
           <a:xfrm>
-            <a:off x="7231446" y="3880104"/>
+            <a:off x="6473192" y="3880104"/>
+            <a:ext cx="1725300" cy="1688592"/>
+          </a:xfrm>
+          <a:prstGeom prst="rect">
+            <a:avLst/>
+          </a:prstGeom>
+        </p:spPr>
+      </p:pic>
+      <p:pic>
+        <p:nvPicPr>
+          <p:cNvPr id="7" name="Picture 6" descr="demo_push.png"/>
+          <p:cNvPicPr>
+            <a:picLocks noChangeAspect="1"/>
+          </p:cNvPicPr>
+          <p:nvPr/>
+        </p:nvPicPr>
+        <p:blipFill>
+          <a:blip r:embed="rId5"/>
+          <a:stretch>
+            <a:fillRect/>
+          </a:stretch>
+        </p:blipFill>
+        <p:spPr>
+          <a:xfrm>
+            <a:off x="8472812" y="3880104"/>
             <a:ext cx="2181098" cy="1688592"/>
           </a:xfrm>
           <a:prstGeom prst="rect">
@@ -14949,7 +14973,7 @@
       </p:pic>
       <p:sp>
         <p:nvSpPr>
-          <p:cNvPr id="7" name="NoteBox"/>
+          <p:cNvPr id="8" name="NoteBox"/>
           <p:cNvSpPr txBox="1"/>
           <p:nvPr/>
         </p:nvSpPr>
@@ -14983,7 +15007,7 @@
       </p:sp>
       <p:sp>
         <p:nvSpPr>
-          <p:cNvPr id="8" name="Footer"/>
+          <p:cNvPr id="9" name="Footer"/>
           <p:cNvSpPr txBox="1"/>
           <p:nvPr/>
         </p:nvSpPr>
@@ -15012,7 +15036,7 @@
       </p:sp>
       <p:sp>
         <p:nvSpPr>
-          <p:cNvPr id="9" name="PageNo"/>
+          <p:cNvPr id="10" name="PageNo"/>
           <p:cNvSpPr txBox="1"/>
           <p:nvPr/>
         </p:nvSpPr>

</xml_diff>

<commit_message>
One figure goes beside the text, not under it
A single portrait-ish image under a short bullet list wastes the entire right
half of the slide and comes out postage-stamp sized. Beside the text it gets
two to three times the area for nothing, so a lone figure now takes the right
column and the bullets wrap into a narrower one. Wide-and-short images are the
exception and stay below, where they can use the full width; so do rows of two
or more.

The narrowing had a trap in it. Setting width alone on an INHERITED placeholder
makes python-pptx write a partial xfrm, and the position collapses to the slide
origin, so the bullets landed on top of the title. All four geometry values now
get pinned, read from the inherited ones first.
</commit_message>
<xml_diff>
--- a/tutorial_HIL_driver.pptx
+++ b/tutorial_HIL_driver.pptx
@@ -4924,7 +4924,12 @@
             <p:ph idx="1"/>
           </p:nvPr>
         </p:nvSpPr>
-        <p:spPr/>
+        <p:spPr>
+          <a:xfrm>
+            <a:off x="642552" y="1313782"/>
+            <a:ext cx="10936224" cy="5203976"/>
+          </a:xfrm>
+        </p:spPr>
         <p:txBody>
           <a:bodyPr wrap="square"/>
           <a:lstStyle/>
@@ -5936,7 +5941,12 @@
             <p:ph idx="1"/>
           </p:nvPr>
         </p:nvSpPr>
-        <p:spPr/>
+        <p:spPr>
+          <a:xfrm>
+            <a:off x="642552" y="1313782"/>
+            <a:ext cx="10936224" cy="5203976"/>
+          </a:xfrm>
+        </p:spPr>
         <p:txBody>
           <a:bodyPr wrap="square"/>
           <a:lstStyle/>
@@ -6164,7 +6174,12 @@
             <p:ph idx="1"/>
           </p:nvPr>
         </p:nvSpPr>
-        <p:spPr/>
+        <p:spPr>
+          <a:xfrm>
+            <a:off x="642552" y="1313782"/>
+            <a:ext cx="10936224" cy="5203976"/>
+          </a:xfrm>
+        </p:spPr>
         <p:txBody>
           <a:bodyPr wrap="square"/>
           <a:lstStyle/>
@@ -6368,7 +6383,12 @@
             <p:ph idx="1"/>
           </p:nvPr>
         </p:nvSpPr>
-        <p:spPr/>
+        <p:spPr>
+          <a:xfrm>
+            <a:off x="642552" y="1313782"/>
+            <a:ext cx="10936224" cy="5203976"/>
+          </a:xfrm>
+        </p:spPr>
         <p:txBody>
           <a:bodyPr wrap="square"/>
           <a:lstStyle/>
@@ -9132,7 +9152,12 @@
             <p:ph idx="1"/>
           </p:nvPr>
         </p:nvSpPr>
-        <p:spPr/>
+        <p:spPr>
+          <a:xfrm>
+            <a:off x="642552" y="1313782"/>
+            <a:ext cx="10936224" cy="5203976"/>
+          </a:xfrm>
+        </p:spPr>
         <p:txBody>
           <a:bodyPr wrap="square"/>
           <a:lstStyle/>
@@ -9376,7 +9401,12 @@
             <p:ph idx="1"/>
           </p:nvPr>
         </p:nvSpPr>
-        <p:spPr/>
+        <p:spPr>
+          <a:xfrm>
+            <a:off x="642552" y="1313782"/>
+            <a:ext cx="10936224" cy="5203976"/>
+          </a:xfrm>
+        </p:spPr>
         <p:txBody>
           <a:bodyPr wrap="square"/>
           <a:lstStyle/>
@@ -9685,7 +9715,12 @@
             <p:ph idx="1"/>
           </p:nvPr>
         </p:nvSpPr>
-        <p:spPr/>
+        <p:spPr>
+          <a:xfrm>
+            <a:off x="642552" y="1313782"/>
+            <a:ext cx="10936224" cy="5203976"/>
+          </a:xfrm>
+        </p:spPr>
         <p:txBody>
           <a:bodyPr wrap="square"/>
           <a:lstStyle/>
@@ -9929,7 +9964,12 @@
             <p:ph idx="1"/>
           </p:nvPr>
         </p:nvSpPr>
-        <p:spPr/>
+        <p:spPr>
+          <a:xfrm>
+            <a:off x="642552" y="1313782"/>
+            <a:ext cx="6446520" cy="5203976"/>
+          </a:xfrm>
+        </p:spPr>
         <p:txBody>
           <a:bodyPr wrap="square"/>
           <a:lstStyle/>
@@ -10040,8 +10080,8 @@
         </p:blipFill>
         <p:spPr>
           <a:xfrm>
-            <a:off x="5272632" y="4311903"/>
-            <a:ext cx="1643686" cy="1256792"/>
+            <a:off x="7269480" y="1707707"/>
+            <a:ext cx="4526280" cy="3460873"/>
           </a:xfrm>
           <a:prstGeom prst="rect">
             <a:avLst/>
@@ -10310,7 +10350,12 @@
             <p:ph idx="1"/>
           </p:nvPr>
         </p:nvSpPr>
-        <p:spPr/>
+        <p:spPr>
+          <a:xfrm>
+            <a:off x="642552" y="1313782"/>
+            <a:ext cx="10936224" cy="5203976"/>
+          </a:xfrm>
+        </p:spPr>
         <p:txBody>
           <a:bodyPr wrap="square"/>
           <a:lstStyle/>
@@ -13583,7 +13628,12 @@
             <p:ph idx="1"/>
           </p:nvPr>
         </p:nvSpPr>
-        <p:spPr/>
+        <p:spPr>
+          <a:xfrm>
+            <a:off x="642552" y="1313782"/>
+            <a:ext cx="10936224" cy="5203976"/>
+          </a:xfrm>
+        </p:spPr>
         <p:txBody>
           <a:bodyPr wrap="square"/>
           <a:lstStyle/>
@@ -14785,7 +14835,12 @@
             <p:ph idx="1"/>
           </p:nvPr>
         </p:nvSpPr>
-        <p:spPr/>
+        <p:spPr>
+          <a:xfrm>
+            <a:off x="642552" y="1313782"/>
+            <a:ext cx="10936224" cy="5203976"/>
+          </a:xfrm>
+        </p:spPr>
         <p:txBody>
           <a:bodyPr wrap="square"/>
           <a:lstStyle/>
@@ -15114,114 +15169,119 @@
             <p:ph idx="1"/>
           </p:nvPr>
         </p:nvSpPr>
-        <p:spPr/>
+        <p:spPr>
+          <a:xfrm>
+            <a:off x="642552" y="1313782"/>
+            <a:ext cx="6446520" cy="5203976"/>
+          </a:xfrm>
+        </p:spPr>
         <p:txBody>
           <a:bodyPr wrap="square"/>
           <a:lstStyle/>
           <a:p>
             <a:pPr>
               <a:spcAft>
-                <a:spcPts val="900"/>
-              </a:spcAft>
-            </a:pPr>
-            <a:r>
-              <a:rPr sz="1800">
+                <a:spcPts val="500"/>
+              </a:spcAft>
+            </a:pPr>
+            <a:r>
+              <a:rPr sz="1400">
                 <a:latin typeface="Consolas"/>
               </a:rPr>
               <a:t>WHAT</a:t>
             </a:r>
             <a:r>
-              <a:rPr sz="2000"/>
+              <a:rPr sz="1600"/>
               <a:t>  click where the push lands, set direction and magnitude, fire a measured impulse, watch the controller recover or fail</a:t>
             </a:r>
           </a:p>
           <a:p>
             <a:pPr>
               <a:spcAft>
-                <a:spcPts val="900"/>
-              </a:spcAft>
-            </a:pPr>
-            <a:r>
-              <a:rPr sz="1800">
+                <a:spcPts val="500"/>
+              </a:spcAft>
+            </a:pPr>
+            <a:r>
+              <a:rPr sz="1400">
                 <a:latin typeface="Consolas"/>
               </a:rPr>
               <a:t>WHY</a:t>
             </a:r>
             <a:r>
-              <a:rPr sz="2000"/>
+              <a:rPr sz="1600"/>
               <a:t>   robustness testing that produces a NUMBER, so the result can go in a report and somebody else can reproduce it</a:t>
             </a:r>
           </a:p>
           <a:p>
             <a:pPr>
               <a:spcAft>
-                <a:spcPts val="900"/>
-              </a:spcAft>
-            </a:pPr>
-            <a:r>
-              <a:rPr sz="2000"/>
+                <a:spcPts val="500"/>
+              </a:spcAft>
+            </a:pPr>
+            <a:r>
+              <a:rPr sz="1600"/>
               <a:t>Forward at the base COM: </a:t>
             </a:r>
             <a:r>
-              <a:rPr sz="1800">
+              <a:rPr sz="1400">
                 <a:latin typeface="Consolas"/>
               </a:rPr>
               <a:t>325 N</a:t>
             </a:r>
             <a:r>
-              <a:rPr sz="2000"/>
+              <a:rPr sz="1600"/>
               <a:t> recovers, </a:t>
             </a:r>
             <a:r>
-              <a:rPr sz="1800">
+              <a:rPr sz="1400">
                 <a:latin typeface="Consolas"/>
               </a:rPr>
               <a:t>330 N</a:t>
             </a:r>
             <a:r>
-              <a:rPr sz="2000"/>
+              <a:rPr sz="1600"/>
               <a:t> does not</a:t>
             </a:r>
           </a:p>
           <a:p>
             <a:pPr>
               <a:spcAft>
-                <a:spcPts val="900"/>
-              </a:spcAft>
-            </a:pPr>
-            <a:r>
-              <a:rPr sz="2000"/>
+                <a:spcPts val="500"/>
+              </a:spcAft>
+            </a:pPr>
+            <a:r>
+              <a:rPr sz="1600"/>
               <a:t>Sideways: </a:t>
             </a:r>
             <a:r>
-              <a:rPr sz="1800">
+              <a:rPr sz="1400">
                 <a:latin typeface="Consolas"/>
               </a:rPr>
               <a:t>280 N</a:t>
             </a:r>
             <a:r>
-              <a:rPr sz="2000"/>
+              <a:rPr sz="1600"/>
               <a:t> recovers, </a:t>
             </a:r>
             <a:r>
-              <a:rPr sz="1800">
+              <a:rPr sz="1400">
                 <a:latin typeface="Consolas"/>
               </a:rPr>
               <a:t>290 N</a:t>
             </a:r>
             <a:r>
-              <a:rPr sz="2000"/>
+              <a:rPr sz="1600"/>
               <a:t> does not</a:t>
             </a:r>
           </a:p>
           <a:p>
             <a:pPr>
               <a:spcAft>
-                <a:spcPts val="900"/>
-              </a:spcAft>
-            </a:pPr>
-            <a:r>
-              <a:rPr sz="2000"/>
+                <a:spcPts val="500"/>
+              </a:spcAft>
+            </a:pPr>
+            <a:r>
+              <a:rPr sz="1600"/>
               <a:t>Same impulse, applied 5 cm higher up the torso: the verdict flips</a:t>
             </a:r>
           </a:p>
@@ -15243,8 +15303,8 @@
         </p:blipFill>
         <p:spPr>
           <a:xfrm>
-            <a:off x="5282797" y="4311903"/>
-            <a:ext cx="1623356" cy="1256792"/>
+            <a:off x="7269480" y="1686035"/>
+            <a:ext cx="4526280" cy="3504216"/>
           </a:xfrm>
           <a:prstGeom prst="rect">
             <a:avLst/>
@@ -15394,7 +15454,12 @@
             <p:ph idx="1"/>
           </p:nvPr>
         </p:nvSpPr>
-        <p:spPr/>
+        <p:spPr>
+          <a:xfrm>
+            <a:off x="642552" y="1313782"/>
+            <a:ext cx="10936224" cy="5203976"/>
+          </a:xfrm>
+        </p:spPr>
         <p:txBody>
           <a:bodyPr wrap="square"/>
           <a:lstStyle/>
@@ -15908,7 +15973,12 @@
             <p:ph idx="1"/>
           </p:nvPr>
         </p:nvSpPr>
-        <p:spPr/>
+        <p:spPr>
+          <a:xfrm>
+            <a:off x="642552" y="1313782"/>
+            <a:ext cx="10936224" cy="5203976"/>
+          </a:xfrm>
+        </p:spPr>
         <p:txBody>
           <a:bodyPr wrap="square"/>
           <a:lstStyle/>
@@ -16145,7 +16215,12 @@
             <p:ph idx="1"/>
           </p:nvPr>
         </p:nvSpPr>
-        <p:spPr/>
+        <p:spPr>
+          <a:xfrm>
+            <a:off x="642552" y="1313782"/>
+            <a:ext cx="6446520" cy="5203976"/>
+          </a:xfrm>
+        </p:spPr>
         <p:txBody>
           <a:bodyPr wrap="square"/>
           <a:lstStyle/>
@@ -16223,8 +16298,8 @@
         </p:blipFill>
         <p:spPr>
           <a:xfrm>
-            <a:off x="4875125" y="4197603"/>
-            <a:ext cx="2438701" cy="1371092"/>
+            <a:off x="7269480" y="2165756"/>
+            <a:ext cx="4526280" cy="2544775"/>
           </a:xfrm>
           <a:prstGeom prst="rect">
             <a:avLst/>
@@ -16374,7 +16449,12 @@
             <p:ph idx="1"/>
           </p:nvPr>
         </p:nvSpPr>
-        <p:spPr/>
+        <p:spPr>
+          <a:xfrm>
+            <a:off x="642552" y="1313782"/>
+            <a:ext cx="10936224" cy="5203976"/>
+          </a:xfrm>
+        </p:spPr>
         <p:txBody>
           <a:bodyPr wrap="square"/>
           <a:lstStyle/>
@@ -17213,7 +17293,12 @@
             <p:ph idx="1"/>
           </p:nvPr>
         </p:nvSpPr>
-        <p:spPr/>
+        <p:spPr>
+          <a:xfrm>
+            <a:off x="642552" y="1313782"/>
+            <a:ext cx="10936224" cy="5203976"/>
+          </a:xfrm>
+        </p:spPr>
         <p:txBody>
           <a:bodyPr wrap="square"/>
           <a:lstStyle/>

</xml_diff>

<commit_message>
Fit bullet slides by geometry, not by a line budget that moved
The levers slide ran over the footer, and the cause was the previous commit's
own doing. The shrink test was "13 lines, or 11 if the slide has a note". When
notes were folded INTO the items, `note` became None, so the budget relaxed
from 11 to 13 at exactly the moment the content grew by the note it had
absorbed. Two changes that each looked safe, in opposite directions.

It now measures instead: text starts at 1.44 in and must stop clear of the
footer, a line costs size*1.25 pt, each item costs its paragraph gap, and the
font shrinks until that fits. No magic line count to go stale the next time a
slide's shape changes.

The layout check was also too lenient to catch this. It asked whether text ran
off the PAGE, and this text did not -- it ran into the footer, 0.3 in above the
bottom edge. It now compares against the footer's own measured position on each
slide, which is the thing that was actually being collided with.
</commit_message>
<xml_diff>
--- a/tutorial_HIL_driver.pptx
+++ b/tutorial_HIL_driver.pptx
@@ -6316,178 +6316,178 @@
           <a:p>
             <a:pPr>
               <a:spcAft>
-                <a:spcPts val="900"/>
-              </a:spcAft>
-            </a:pPr>
-            <a:r>
-              <a:rPr sz="1800"/>
+                <a:spcPts val="500"/>
+              </a:spcAft>
+            </a:pPr>
+            <a:r>
+              <a:rPr sz="1700"/>
               <a:t>1.  </a:t>
             </a:r>
             <a:r>
-              <a:rPr sz="1600">
+              <a:rPr sz="1500">
                 <a:latin typeface="Consolas"/>
               </a:rPr>
               <a:t>Step size</a:t>
             </a:r>
             <a:r>
-              <a:rPr sz="1800"/>
+              <a:rPr sz="1700"/>
               <a:t>. Everything scales with steps per second. The largest step that stays stable is the single biggest lever there is.</a:t>
             </a:r>
           </a:p>
           <a:p>
             <a:pPr>
               <a:spcAft>
-                <a:spcPts val="900"/>
-              </a:spcAft>
-            </a:pPr>
-            <a:r>
-              <a:rPr sz="1800"/>
+                <a:spcPts val="500"/>
+              </a:spcAft>
+            </a:pPr>
+            <a:r>
+              <a:rPr sz="1700"/>
               <a:t>2.  </a:t>
             </a:r>
             <a:r>
-              <a:rPr sz="1600">
+              <a:rPr sz="1500">
                 <a:latin typeface="Consolas"/>
               </a:rPr>
               <a:t>Collision geometry</a:t>
             </a:r>
             <a:r>
-              <a:rPr sz="1800"/>
+              <a:rPr sz="1700"/>
               <a:t>. Primitives beat convex hulls beat triangle meshes, by a lot. Most imported assets arrive as the slowest option.</a:t>
             </a:r>
           </a:p>
           <a:p>
             <a:pPr>
               <a:spcAft>
-                <a:spcPts val="900"/>
-              </a:spcAft>
-            </a:pPr>
-            <a:r>
-              <a:rPr sz="1800"/>
+                <a:spcPts val="500"/>
+              </a:spcAft>
+            </a:pPr>
+            <a:r>
+              <a:rPr sz="1700"/>
               <a:t>3.  </a:t>
             </a:r>
             <a:r>
-              <a:rPr sz="1600">
+              <a:rPr sz="1500">
                 <a:latin typeface="Consolas"/>
               </a:rPr>
               <a:t>Which pairs are tested at all</a:t>
             </a:r>
             <a:r>
-              <a:rPr sz="1800"/>
+              <a:rPr sz="1700"/>
               <a:t>. Families and masks remove whole classes of pair from the broadphase, including self-collision.</a:t>
             </a:r>
           </a:p>
           <a:p>
             <a:pPr>
               <a:spcAft>
-                <a:spcPts val="900"/>
-              </a:spcAft>
-            </a:pPr>
-            <a:r>
-              <a:rPr sz="1800"/>
+                <a:spcPts val="500"/>
+              </a:spcAft>
+            </a:pPr>
+            <a:r>
+              <a:rPr sz="1700"/>
               <a:t>4.  </a:t>
             </a:r>
             <a:r>
-              <a:rPr sz="1600">
+              <a:rPr sz="1500">
                 <a:latin typeface="Consolas"/>
               </a:rPr>
               <a:t>Active domains</a:t>
             </a:r>
             <a:r>
-              <a:rPr sz="1800"/>
+              <a:rPr sz="1700"/>
               <a:t>. Let the expensive physics happen only where it matters: deformable terrain near the wheels, fluid near the hull.</a:t>
             </a:r>
           </a:p>
           <a:p>
             <a:pPr>
               <a:spcAft>
-                <a:spcPts val="900"/>
-              </a:spcAft>
-            </a:pPr>
-            <a:r>
-              <a:rPr sz="1800"/>
+                <a:spcPts val="500"/>
+              </a:spcAft>
+            </a:pPr>
+            <a:r>
+              <a:rPr sz="1700"/>
               <a:t>5.  </a:t>
             </a:r>
             <a:r>
-              <a:rPr sz="1600">
+              <a:rPr sz="1500">
                 <a:latin typeface="Consolas"/>
               </a:rPr>
               <a:t>Solver type and iteration cap</a:t>
             </a:r>
             <a:r>
-              <a:rPr sz="1800"/>
+              <a:rPr sz="1700"/>
               <a:t>. Iterations buy convergence and cost time, and you pay out of the same step you wanted to sleep in.</a:t>
             </a:r>
           </a:p>
           <a:p>
             <a:pPr>
               <a:spcAft>
-                <a:spcPts val="900"/>
-              </a:spcAft>
-            </a:pPr>
-            <a:r>
-              <a:rPr sz="1800"/>
+                <a:spcPts val="500"/>
+              </a:spcAft>
+            </a:pPr>
+            <a:r>
+              <a:rPr sz="1700"/>
               <a:t>6.  </a:t>
             </a:r>
             <a:r>
-              <a:rPr sz="1600">
+              <a:rPr sz="1500">
                 <a:latin typeface="Consolas"/>
               </a:rPr>
               <a:t>Threads</a:t>
             </a:r>
             <a:r>
-              <a:rPr sz="1800"/>
+              <a:rPr sz="1700"/>
               <a:t>, </a:t>
             </a:r>
             <a:r>
-              <a:rPr sz="1600">
+              <a:rPr sz="1500">
                 <a:latin typeface="Consolas"/>
               </a:rPr>
               <a:t>sleeping bodies</a:t>
             </a:r>
             <a:r>
-              <a:rPr sz="1800"/>
+              <a:rPr sz="1700"/>
               <a:t>, and </a:t>
             </a:r>
             <a:r>
-              <a:rPr sz="1600">
+              <a:rPr sz="1500">
                 <a:latin typeface="Consolas"/>
               </a:rPr>
               <a:t>model reduction</a:t>
             </a:r>
             <a:r>
-              <a:rPr sz="1800"/>
+              <a:rPr sz="1700"/>
               <a:t> for elastic subassemblies.</a:t>
             </a:r>
           </a:p>
           <a:p>
             <a:pPr>
               <a:spcAft>
-                <a:spcPts val="900"/>
-              </a:spcAft>
-            </a:pPr>
-            <a:r>
-              <a:rPr sz="1800"/>
+                <a:spcPts val="500"/>
+              </a:spcAft>
+            </a:pPr>
+            <a:r>
+              <a:rPr sz="1700"/>
               <a:t>7.  </a:t>
             </a:r>
             <a:r>
-              <a:rPr sz="1600">
+              <a:rPr sz="1500">
                 <a:latin typeface="Consolas"/>
               </a:rPr>
               <a:t>Render less often than you step</a:t>
             </a:r>
             <a:r>
-              <a:rPr sz="1800"/>
+              <a:rPr sz="1700"/>
               <a:t>. Drawing is not free, and the eye does not need 500 Hz.</a:t>
             </a:r>
           </a:p>
           <a:p>
             <a:pPr>
               <a:spcAft>
-                <a:spcPts val="900"/>
-              </a:spcAft>
-            </a:pPr>
-            <a:r>
-              <a:rPr sz="1800"/>
+                <a:spcPts val="500"/>
+              </a:spcAft>
+            </a:pPr>
+            <a:r>
+              <a:rPr sz="1700"/>
               <a:t>None of this is specific to having a human in the loop. It becomes urgent when there is one, because a batch job that runs at 0.6x real time is merely slow, and an interactive one is broken.</a:t>
             </a:r>
           </a:p>

</xml_diff>